<commit_message>
updated lab_04 to 24/25
</commit_message>
<xml_diff>
--- a/lab_04-hello-flutter/lab_04-hello_flutter.pptx
+++ b/lab_04-hello-flutter/lab_04-hello_flutter.pptx
@@ -245,7 +245,7 @@
           <a:p>
             <a:fld id="{81C4B3FE-0320-8142-8396-5C3025C019EC}" type="datetimeFigureOut">
               <a:rPr lang="en-IT" smtClean="0"/>
-              <a:t>3/19/24</a:t>
+              <a:t>3/10/25</a:t>
             </a:fld>
             <a:endParaRPr lang="en-IT"/>
           </a:p>
@@ -3575,7 +3575,13 @@
         </p:spPr>
         <p:txBody>
           <a:bodyPr/>
-          <a:lstStyle/>
+          <a:lstStyle>
+            <a:lvl1pPr>
+              <a:defRPr>
+                <a:latin typeface="Aptos" panose="020B0004020202020204" pitchFamily="34" charset="0"/>
+              </a:defRPr>
+            </a:lvl1pPr>
+          </a:lstStyle>
           <a:p>
             <a:r>
               <a:rPr lang="en-GB" noProof="0" dirty="0"/>
@@ -3624,8 +3630,30 @@
         <p:txBody>
           <a:bodyPr/>
           <a:lstStyle>
+            <a:lvl1pPr>
+              <a:defRPr>
+                <a:latin typeface="Aptos" panose="020B0004020202020204" pitchFamily="34" charset="0"/>
+              </a:defRPr>
+            </a:lvl1pPr>
+            <a:lvl2pPr>
+              <a:defRPr>
+                <a:latin typeface="Aptos" panose="020B0004020202020204" pitchFamily="34" charset="0"/>
+              </a:defRPr>
+            </a:lvl2pPr>
+            <a:lvl3pPr>
+              <a:defRPr>
+                <a:latin typeface="Aptos" panose="020B0004020202020204" pitchFamily="34" charset="0"/>
+              </a:defRPr>
+            </a:lvl3pPr>
+            <a:lvl4pPr>
+              <a:defRPr>
+                <a:latin typeface="Aptos" panose="020B0004020202020204" pitchFamily="34" charset="0"/>
+              </a:defRPr>
+            </a:lvl4pPr>
             <a:lvl5pPr>
-              <a:defRPr/>
+              <a:defRPr>
+                <a:latin typeface="Aptos" panose="020B0004020202020204" pitchFamily="34" charset="0"/>
+              </a:defRPr>
             </a:lvl5pPr>
           </a:lstStyle>
           <a:p>
@@ -3742,10 +3770,17 @@
         <p:spPr/>
         <p:txBody>
           <a:bodyPr/>
-          <a:lstStyle/>
+          <a:lstStyle>
+            <a:lvl1pPr>
+              <a:defRPr>
+                <a:latin typeface="Aptos" panose="020B0004020202020204" pitchFamily="34" charset="0"/>
+              </a:defRPr>
+            </a:lvl1pPr>
+          </a:lstStyle>
           <a:p>
             <a:fld id="{31DE2C5B-556E-47B8-A792-024C2FCA4ACC}" type="slidenum">
               <a:rPr lang="en-GB" smtClean="0"/>
+              <a:pPr/>
               <a:t>‹#›</a:t>
             </a:fld>
             <a:endParaRPr lang="en-GB"/>
@@ -3798,7 +3833,9 @@
           <a:lstStyle/>
           <a:p>
             <a:pPr algn="ctr"/>
-            <a:endParaRPr lang="en-GB" dirty="0"/>
+            <a:endParaRPr lang="en-GB" dirty="0">
+              <a:latin typeface="Aptos" panose="020B0004020202020204" pitchFamily="34" charset="0"/>
+            </a:endParaRPr>
           </a:p>
         </p:txBody>
       </p:sp>
@@ -4238,7 +4275,9 @@
           <a:lstStyle>
             <a:lvl1pPr marL="0" indent="0" algn="ctr">
               <a:buNone/>
-              <a:defRPr sz="4800" b="1"/>
+              <a:defRPr sz="4800" b="1">
+                <a:latin typeface="Aptos" panose="020B0004020202020204" pitchFamily="34" charset="0"/>
+              </a:defRPr>
             </a:lvl1pPr>
             <a:lvl2pPr marL="457200" indent="0" algn="ctr">
               <a:buNone/>
@@ -4324,7 +4363,9 @@
           <a:lstStyle/>
           <a:p>
             <a:pPr algn="ctr"/>
-            <a:endParaRPr lang="en-GB" dirty="0"/>
+            <a:endParaRPr lang="en-GB" dirty="0">
+              <a:latin typeface="Aptos" panose="020B0004020202020204" pitchFamily="34" charset="0"/>
+            </a:endParaRPr>
           </a:p>
         </p:txBody>
       </p:sp>
@@ -4374,7 +4415,9 @@
           <a:lstStyle/>
           <a:p>
             <a:pPr algn="ctr"/>
-            <a:endParaRPr lang="en-GB" dirty="0"/>
+            <a:endParaRPr lang="en-GB" dirty="0">
+              <a:latin typeface="Aptos" panose="020B0004020202020204" pitchFamily="34" charset="0"/>
+            </a:endParaRPr>
           </a:p>
         </p:txBody>
       </p:sp>
@@ -4420,36 +4463,52 @@
           </a:lstStyle>
           <a:p>
             <a:r>
-              <a:rPr lang="it-IT" sz="2800" b="0" dirty="0" err="1"/>
+              <a:rPr lang="it-IT" sz="2800" b="0" dirty="0" err="1">
+                <a:latin typeface="Aptos" panose="020B0004020202020204" pitchFamily="34" charset="0"/>
+              </a:rPr>
               <a:t>Biomedical</a:t>
             </a:r>
             <a:r>
-              <a:rPr lang="it-IT" sz="2800" b="0" dirty="0"/>
+              <a:rPr lang="it-IT" sz="2800" b="0" dirty="0">
+                <a:latin typeface="Aptos" panose="020B0004020202020204" pitchFamily="34" charset="0"/>
+              </a:rPr>
               <a:t> </a:t>
             </a:r>
             <a:r>
-              <a:rPr lang="it-IT" sz="2800" b="0" dirty="0" err="1"/>
+              <a:rPr lang="it-IT" sz="2800" b="0" dirty="0" err="1">
+                <a:latin typeface="Aptos" panose="020B0004020202020204" pitchFamily="34" charset="0"/>
+              </a:rPr>
               <a:t>Wearable</a:t>
             </a:r>
             <a:r>
-              <a:rPr lang="it-IT" sz="2800" b="0" dirty="0"/>
+              <a:rPr lang="it-IT" sz="2800" b="0" dirty="0">
+                <a:latin typeface="Aptos" panose="020B0004020202020204" pitchFamily="34" charset="0"/>
+              </a:rPr>
               <a:t> Technologies </a:t>
             </a:r>
           </a:p>
           <a:p>
             <a:r>
-              <a:rPr lang="it-IT" sz="2800" b="0" dirty="0"/>
+              <a:rPr lang="it-IT" sz="2800" b="0" dirty="0">
+                <a:latin typeface="Aptos" panose="020B0004020202020204" pitchFamily="34" charset="0"/>
+              </a:rPr>
               <a:t>for Healthcare and </a:t>
             </a:r>
             <a:r>
-              <a:rPr lang="it-IT" sz="2800" b="0" dirty="0" err="1"/>
+              <a:rPr lang="it-IT" sz="2800" b="0" dirty="0" err="1">
+                <a:latin typeface="Aptos" panose="020B0004020202020204" pitchFamily="34" charset="0"/>
+              </a:rPr>
               <a:t>Wellbeing</a:t>
             </a:r>
             <a:r>
-              <a:rPr lang="it-IT" sz="2800" b="0" dirty="0"/>
+              <a:rPr lang="it-IT" sz="2800" b="0" dirty="0">
+                <a:latin typeface="Aptos" panose="020B0004020202020204" pitchFamily="34" charset="0"/>
+              </a:rPr>
               <a:t>  </a:t>
             </a:r>
-            <a:endParaRPr lang="en-GB" sz="2800" b="0" dirty="0"/>
+            <a:endParaRPr lang="en-GB" sz="2800" b="0" dirty="0">
+              <a:latin typeface="Aptos" panose="020B0004020202020204" pitchFamily="34" charset="0"/>
+            </a:endParaRPr>
           </a:p>
         </p:txBody>
       </p:sp>
@@ -4500,8 +4559,10 @@
               </a:spcAft>
             </a:pPr>
             <a:r>
-              <a:rPr lang="it-IT" sz="2800" dirty="0"/>
-              <a:t>A.Y. 2023-2024</a:t>
+              <a:rPr lang="it-IT" sz="2800" dirty="0">
+                <a:latin typeface="Aptos" panose="020B0004020202020204" pitchFamily="34" charset="0"/>
+              </a:rPr>
+              <a:t>A.Y. 2024-2025</a:t>
             </a:r>
           </a:p>
         </p:txBody>
@@ -4540,7 +4601,7 @@
                 <a:effectLst/>
                 <a:uLnTx/>
                 <a:uFillTx/>
-                <a:latin typeface="Palatino Linotype" panose="02040502050505030304" pitchFamily="18" charset="0"/>
+                <a:latin typeface="Aptos" panose="020B0004020202020204" pitchFamily="34" charset="0"/>
                 <a:ea typeface="+mj-ea"/>
                 <a:cs typeface="+mj-cs"/>
               </a:rPr>
@@ -4557,7 +4618,7 @@
                 <a:effectLst/>
                 <a:uLnTx/>
                 <a:uFillTx/>
-                <a:latin typeface="Palatino Linotype" panose="02040502050505030304" pitchFamily="18" charset="0"/>
+                <a:latin typeface="Aptos" panose="020B0004020202020204" pitchFamily="34" charset="0"/>
                 <a:ea typeface="+mj-ea"/>
                 <a:cs typeface="+mj-cs"/>
               </a:rPr>
@@ -4574,7 +4635,7 @@
                 <a:effectLst/>
                 <a:uLnTx/>
                 <a:uFillTx/>
-                <a:latin typeface="Palatino Linotype" panose="02040502050505030304" pitchFamily="18" charset="0"/>
+                <a:latin typeface="Aptos" panose="020B0004020202020204" pitchFamily="34" charset="0"/>
                 <a:ea typeface="+mj-ea"/>
                 <a:cs typeface="+mj-cs"/>
               </a:rPr>
@@ -4590,7 +4651,7 @@
                 <a:effectLst/>
                 <a:uLnTx/>
                 <a:uFillTx/>
-                <a:latin typeface="Palatino Linotype" panose="02040502050505030304" pitchFamily="18" charset="0"/>
+                <a:latin typeface="Aptos" panose="020B0004020202020204" pitchFamily="34" charset="0"/>
                 <a:ea typeface="+mj-ea"/>
                 <a:cs typeface="+mj-cs"/>
               </a:rPr>
@@ -4607,7 +4668,7 @@
                 <a:effectLst/>
                 <a:uLnTx/>
                 <a:uFillTx/>
-                <a:latin typeface="Palatino Linotype" panose="02040502050505030304" pitchFamily="18" charset="0"/>
+                <a:latin typeface="Aptos" panose="020B0004020202020204" pitchFamily="34" charset="0"/>
                 <a:ea typeface="+mj-ea"/>
                 <a:cs typeface="+mj-cs"/>
               </a:rPr>
@@ -4624,13 +4685,15 @@
                 <a:effectLst/>
                 <a:uLnTx/>
                 <a:uFillTx/>
-                <a:latin typeface="Palatino Linotype" panose="02040502050505030304" pitchFamily="18" charset="0"/>
+                <a:latin typeface="Aptos" panose="020B0004020202020204" pitchFamily="34" charset="0"/>
                 <a:ea typeface="+mj-ea"/>
                 <a:cs typeface="+mj-cs"/>
               </a:rPr>
               <a:t>Engineering</a:t>
             </a:r>
-            <a:endParaRPr lang="en-GB" sz="1100" cap="small" baseline="0" dirty="0"/>
+            <a:endParaRPr lang="en-GB" sz="1100" cap="small" baseline="0" dirty="0">
+              <a:latin typeface="Aptos" panose="020B0004020202020204" pitchFamily="34" charset="0"/>
+            </a:endParaRPr>
           </a:p>
         </p:txBody>
       </p:sp>
@@ -4740,7 +4803,9 @@
           </a:bodyPr>
           <a:lstStyle>
             <a:lvl1pPr>
-              <a:defRPr sz="3200"/>
+              <a:defRPr sz="3200">
+                <a:latin typeface="Aptos" panose="020B0004020202020204" pitchFamily="34" charset="0"/>
+              </a:defRPr>
             </a:lvl1pPr>
           </a:lstStyle>
           <a:p>
@@ -5140,12 +5205,14 @@
                     <a:tint val="75000"/>
                   </a:schemeClr>
                 </a:solidFill>
+                <a:latin typeface="Aptos" panose="020B0004020202020204" pitchFamily="34" charset="0"/>
               </a:defRPr>
             </a:lvl1pPr>
           </a:lstStyle>
           <a:p>
             <a:fld id="{31DE2C5B-556E-47B8-A792-024C2FCA4ACC}" type="slidenum">
               <a:rPr lang="en-GB" smtClean="0"/>
+              <a:pPr/>
               <a:t>‹#›</a:t>
             </a:fld>
             <a:endParaRPr lang="en-GB"/>
@@ -5181,7 +5248,7 @@
           <a:solidFill>
             <a:schemeClr val="tx1"/>
           </a:solidFill>
-          <a:latin typeface="Palatino Linotype" panose="02040502050505030304" pitchFamily="18" charset="0"/>
+          <a:latin typeface="Aptos" panose="020B0004020202020204" pitchFamily="34" charset="0"/>
           <a:ea typeface="+mj-ea"/>
           <a:cs typeface="+mj-cs"/>
         </a:defRPr>
@@ -5204,7 +5271,7 @@
           <a:solidFill>
             <a:schemeClr val="tx1"/>
           </a:solidFill>
-          <a:latin typeface="Palatino Linotype" panose="02040502050505030304" pitchFamily="18" charset="0"/>
+          <a:latin typeface="Aptos" panose="020B0004020202020204" pitchFamily="34" charset="0"/>
           <a:ea typeface="+mn-ea"/>
           <a:cs typeface="+mn-cs"/>
         </a:defRPr>
@@ -5225,7 +5292,7 @@
           <a:solidFill>
             <a:schemeClr val="tx1"/>
           </a:solidFill>
-          <a:latin typeface="Palatino Linotype" panose="02040502050505030304" pitchFamily="18" charset="0"/>
+          <a:latin typeface="Aptos" panose="020B0004020202020204" pitchFamily="34" charset="0"/>
           <a:ea typeface="+mn-ea"/>
           <a:cs typeface="+mn-cs"/>
         </a:defRPr>
@@ -5246,7 +5313,7 @@
           <a:solidFill>
             <a:schemeClr val="tx1"/>
           </a:solidFill>
-          <a:latin typeface="Palatino Linotype" panose="02040502050505030304" pitchFamily="18" charset="0"/>
+          <a:latin typeface="Aptos" panose="020B0004020202020204" pitchFamily="34" charset="0"/>
           <a:ea typeface="+mn-ea"/>
           <a:cs typeface="+mn-cs"/>
         </a:defRPr>
@@ -5267,7 +5334,7 @@
           <a:solidFill>
             <a:schemeClr val="tx1"/>
           </a:solidFill>
-          <a:latin typeface="Palatino Linotype" panose="02040502050505030304" pitchFamily="18" charset="0"/>
+          <a:latin typeface="Aptos" panose="020B0004020202020204" pitchFamily="34" charset="0"/>
           <a:ea typeface="+mn-ea"/>
           <a:cs typeface="+mn-cs"/>
         </a:defRPr>
@@ -5288,7 +5355,7 @@
           <a:solidFill>
             <a:schemeClr val="tx1"/>
           </a:solidFill>
-          <a:latin typeface="Palatino Linotype" panose="02040502050505030304" pitchFamily="18" charset="0"/>
+          <a:latin typeface="Aptos" panose="020B0004020202020204" pitchFamily="34" charset="0"/>
           <a:ea typeface="+mn-ea"/>
           <a:cs typeface="+mn-cs"/>
         </a:defRPr>
@@ -6614,36 +6681,38 @@
           <a:p>
             <a:r>
               <a:rPr lang="en-GB" dirty="0">
-                <a:latin typeface="Palatino Linotype" panose="02040502050505030304" pitchFamily="18" charset="0"/>
+                <a:latin typeface="Aptos" panose="020B0004020202020204" pitchFamily="34" charset="0"/>
               </a:rPr>
               <a:t>To run an app using the Flutter framework we can use the </a:t>
             </a:r>
             <a:r>
               <a:rPr lang="en-GB" b="1" dirty="0" err="1">
-                <a:latin typeface="Courier" pitchFamily="2" charset="0"/>
+                <a:latin typeface="Courier New" panose="02070309020205020404" pitchFamily="49" charset="0"/>
+                <a:cs typeface="Courier New" panose="02070309020205020404" pitchFamily="49" charset="0"/>
               </a:rPr>
               <a:t>runApp</a:t>
             </a:r>
             <a:r>
               <a:rPr lang="en-GB" dirty="0">
-                <a:latin typeface="Palatino Linotype" panose="02040502050505030304" pitchFamily="18" charset="0"/>
+                <a:latin typeface="Aptos" panose="020B0004020202020204" pitchFamily="34" charset="0"/>
               </a:rPr>
               <a:t> method which takes a </a:t>
             </a:r>
             <a:r>
               <a:rPr lang="en-GB" b="1" dirty="0">
-                <a:latin typeface="Courier" pitchFamily="2" charset="0"/>
+                <a:latin typeface="Courier New" panose="02070309020205020404" pitchFamily="49" charset="0"/>
+                <a:cs typeface="Courier New" panose="02070309020205020404" pitchFamily="49" charset="0"/>
               </a:rPr>
               <a:t>Widget</a:t>
             </a:r>
             <a:r>
               <a:rPr lang="en-GB" dirty="0">
-                <a:latin typeface="Palatino Linotype" panose="02040502050505030304" pitchFamily="18" charset="0"/>
+                <a:latin typeface="Aptos" panose="020B0004020202020204" pitchFamily="34" charset="0"/>
               </a:rPr>
               <a:t> object as an input.</a:t>
             </a:r>
             <a:endParaRPr lang="en-IT" dirty="0">
-              <a:latin typeface="Palatino Linotype" panose="02040502050505030304" pitchFamily="18" charset="0"/>
+              <a:latin typeface="Aptos" panose="020B0004020202020204" pitchFamily="34" charset="0"/>
             </a:endParaRPr>
           </a:p>
         </p:txBody>
@@ -6684,24 +6753,25 @@
             <a:pPr algn="ctr"/>
             <a:r>
               <a:rPr lang="en-GB" b="1" dirty="0">
-                <a:latin typeface="Palatino Linotype" panose="02040502050505030304" pitchFamily="18" charset="0"/>
+                <a:latin typeface="Aptos" panose="020B0004020202020204" pitchFamily="34" charset="0"/>
               </a:rPr>
               <a:t>What’s a </a:t>
             </a:r>
             <a:r>
               <a:rPr lang="en-GB" b="1" dirty="0">
-                <a:latin typeface="Courier" pitchFamily="2" charset="0"/>
+                <a:latin typeface="Courier New" panose="02070309020205020404" pitchFamily="49" charset="0"/>
+                <a:cs typeface="Courier New" panose="02070309020205020404" pitchFamily="49" charset="0"/>
               </a:rPr>
               <a:t>Widget</a:t>
             </a:r>
             <a:r>
               <a:rPr lang="en-GB" b="1" dirty="0">
-                <a:latin typeface="Palatino Linotype" panose="02040502050505030304" pitchFamily="18" charset="0"/>
+                <a:latin typeface="Aptos" panose="020B0004020202020204" pitchFamily="34" charset="0"/>
               </a:rPr>
               <a:t>?</a:t>
             </a:r>
             <a:endParaRPr lang="en-IT" dirty="0">
-              <a:latin typeface="Palatino Linotype" panose="02040502050505030304" pitchFamily="18" charset="0"/>
+              <a:latin typeface="Aptos" panose="020B0004020202020204" pitchFamily="34" charset="0"/>
             </a:endParaRPr>
           </a:p>
         </p:txBody>
@@ -7494,12 +7564,25 @@
             <a:pPr algn="ctr"/>
             <a:r>
               <a:rPr lang="en-GB" b="1" dirty="0">
-                <a:latin typeface="Palatino Linotype" panose="02040502050505030304" pitchFamily="18" charset="0"/>
-              </a:rPr>
-              <a:t>But how Widgets are combined together?</a:t>
+                <a:latin typeface="Aptos" panose="020B0004020202020204" pitchFamily="34" charset="0"/>
+              </a:rPr>
+              <a:t>But how </a:t>
+            </a:r>
+            <a:r>
+              <a:rPr lang="en-GB" b="1" dirty="0">
+                <a:latin typeface="Courier New" panose="02070309020205020404" pitchFamily="49" charset="0"/>
+                <a:cs typeface="Courier New" panose="02070309020205020404" pitchFamily="49" charset="0"/>
+              </a:rPr>
+              <a:t>Widgets</a:t>
+            </a:r>
+            <a:r>
+              <a:rPr lang="en-GB" b="1" dirty="0">
+                <a:latin typeface="Aptos" panose="020B0004020202020204" pitchFamily="34" charset="0"/>
+              </a:rPr>
+              <a:t> are combined together?</a:t>
             </a:r>
             <a:endParaRPr lang="en-IT" dirty="0">
-              <a:latin typeface="Palatino Linotype" panose="02040502050505030304" pitchFamily="18" charset="0"/>
+              <a:latin typeface="Aptos" panose="020B0004020202020204" pitchFamily="34" charset="0"/>
             </a:endParaRPr>
           </a:p>
         </p:txBody>
@@ -7533,12 +7616,25 @@
           <a:p>
             <a:r>
               <a:rPr lang="en-GB" dirty="0">
-                <a:latin typeface="Palatino Linotype" panose="02040502050505030304" pitchFamily="18" charset="0"/>
-              </a:rPr>
-              <a:t>Key method for building the Widget that must be implemented</a:t>
+                <a:latin typeface="Aptos" panose="020B0004020202020204" pitchFamily="34" charset="0"/>
+              </a:rPr>
+              <a:t>Key method for building the </a:t>
+            </a:r>
+            <a:r>
+              <a:rPr lang="en-GB" dirty="0">
+                <a:latin typeface="Courier New" panose="02070309020205020404" pitchFamily="49" charset="0"/>
+                <a:cs typeface="Courier New" panose="02070309020205020404" pitchFamily="49" charset="0"/>
+              </a:rPr>
+              <a:t>Widget</a:t>
+            </a:r>
+            <a:r>
+              <a:rPr lang="en-GB" dirty="0">
+                <a:latin typeface="Aptos" panose="020B0004020202020204" pitchFamily="34" charset="0"/>
+              </a:rPr>
+              <a:t> that must be implemented</a:t>
             </a:r>
             <a:endParaRPr lang="en-IT" dirty="0">
-              <a:latin typeface="Palatino Linotype" panose="02040502050505030304" pitchFamily="18" charset="0"/>
+              <a:latin typeface="Aptos" panose="020B0004020202020204" pitchFamily="34" charset="0"/>
             </a:endParaRPr>
           </a:p>
         </p:txBody>
@@ -9353,13 +9449,13 @@
           <a:p>
             <a:r>
               <a:rPr lang="en-GB" dirty="0" err="1">
-                <a:latin typeface="Palatino Linotype" panose="02040502050505030304" pitchFamily="18" charset="0"/>
+                <a:latin typeface="Aptos" panose="020B0004020202020204" pitchFamily="34" charset="0"/>
               </a:rPr>
               <a:t>MyApp</a:t>
             </a:r>
             <a:r>
               <a:rPr lang="en-GB" dirty="0">
-                <a:latin typeface="Palatino Linotype" panose="02040502050505030304" pitchFamily="18" charset="0"/>
+                <a:latin typeface="Aptos" panose="020B0004020202020204" pitchFamily="34" charset="0"/>
               </a:rPr>
               <a:t> is not just a Widget, it is a </a:t>
             </a:r>
@@ -10020,18 +10116,18 @@
           <a:p>
             <a:r>
               <a:rPr lang="en-GB" dirty="0" err="1">
-                <a:latin typeface="Palatino Linotype" panose="02040502050505030304" pitchFamily="18" charset="0"/>
+                <a:latin typeface="Aptos" panose="020B0004020202020204" pitchFamily="34" charset="0"/>
               </a:rPr>
               <a:t>my_first_app</a:t>
             </a:r>
             <a:r>
               <a:rPr lang="en-GB" dirty="0">
-                <a:latin typeface="Palatino Linotype" panose="02040502050505030304" pitchFamily="18" charset="0"/>
+                <a:latin typeface="Aptos" panose="020B0004020202020204" pitchFamily="34" charset="0"/>
               </a:rPr>
               <a:t> information (name, description, version, …)</a:t>
             </a:r>
             <a:endParaRPr lang="en-IT" dirty="0">
-              <a:latin typeface="Courier" pitchFamily="2" charset="0"/>
+              <a:latin typeface="Aptos" panose="020B0004020202020204" pitchFamily="34" charset="0"/>
             </a:endParaRPr>
           </a:p>
         </p:txBody>
@@ -10065,24 +10161,24 @@
           <a:p>
             <a:r>
               <a:rPr lang="en-GB" dirty="0">
-                <a:latin typeface="Palatino Linotype" panose="02040502050505030304" pitchFamily="18" charset="0"/>
+                <a:latin typeface="Aptos" panose="020B0004020202020204" pitchFamily="34" charset="0"/>
               </a:rPr>
               <a:t>Flutter </a:t>
             </a:r>
             <a:r>
               <a:rPr lang="en-GB" dirty="0" err="1">
-                <a:latin typeface="Palatino Linotype" panose="02040502050505030304" pitchFamily="18" charset="0"/>
+                <a:latin typeface="Aptos" panose="020B0004020202020204" pitchFamily="34" charset="0"/>
               </a:rPr>
               <a:t>sdk</a:t>
             </a:r>
             <a:r>
               <a:rPr lang="en-GB" dirty="0">
-                <a:latin typeface="Palatino Linotype" panose="02040502050505030304" pitchFamily="18" charset="0"/>
+                <a:latin typeface="Aptos" panose="020B0004020202020204" pitchFamily="34" charset="0"/>
               </a:rPr>
               <a:t> version to be used</a:t>
             </a:r>
             <a:endParaRPr lang="en-IT" dirty="0">
-              <a:latin typeface="Courier" pitchFamily="2" charset="0"/>
+              <a:latin typeface="Aptos" panose="020B0004020202020204" pitchFamily="34" charset="0"/>
             </a:endParaRPr>
           </a:p>
         </p:txBody>
@@ -10157,12 +10253,12 @@
           <a:p>
             <a:r>
               <a:rPr lang="en-GB" dirty="0">
-                <a:latin typeface="Palatino Linotype" panose="02040502050505030304" pitchFamily="18" charset="0"/>
+                <a:latin typeface="Aptos" panose="020B0004020202020204" pitchFamily="34" charset="0"/>
               </a:rPr>
               <a:t>App dependencies: what the app needs in order to work: other packages? Other libraries? Put them here.</a:t>
             </a:r>
             <a:endParaRPr lang="en-IT" dirty="0">
-              <a:latin typeface="Courier" pitchFamily="2" charset="0"/>
+              <a:latin typeface="Aptos" panose="020B0004020202020204" pitchFamily="34" charset="0"/>
             </a:endParaRPr>
           </a:p>
         </p:txBody>
@@ -10278,12 +10374,12 @@
           <a:p>
             <a:r>
               <a:rPr lang="en-GB" dirty="0">
-                <a:latin typeface="Palatino Linotype" panose="02040502050505030304" pitchFamily="18" charset="0"/>
+                <a:latin typeface="Aptos" panose="020B0004020202020204" pitchFamily="34" charset="0"/>
               </a:rPr>
               <a:t>App dependencies while developing the app</a:t>
             </a:r>
             <a:endParaRPr lang="en-IT" dirty="0">
-              <a:latin typeface="Courier" pitchFamily="2" charset="0"/>
+              <a:latin typeface="Aptos" panose="020B0004020202020204" pitchFamily="34" charset="0"/>
             </a:endParaRPr>
           </a:p>
         </p:txBody>
@@ -10317,12 +10413,12 @@
           <a:p>
             <a:r>
               <a:rPr lang="en-GB" dirty="0">
-                <a:latin typeface="Palatino Linotype" panose="02040502050505030304" pitchFamily="18" charset="0"/>
+                <a:latin typeface="Aptos" panose="020B0004020202020204" pitchFamily="34" charset="0"/>
               </a:rPr>
               <a:t>Information for the Flutter environment such as where to find assets.</a:t>
             </a:r>
             <a:endParaRPr lang="en-IT" dirty="0">
-              <a:latin typeface="Courier" pitchFamily="2" charset="0"/>
+              <a:latin typeface="Aptos" panose="020B0004020202020204" pitchFamily="34" charset="0"/>
             </a:endParaRPr>
           </a:p>
         </p:txBody>
@@ -10586,6 +10682,7 @@
             </a:pPr>
             <a:r>
               <a:rPr lang="en-IT" sz="1600" dirty="0">
+                <a:latin typeface="Aptos" panose="020B0004020202020204" pitchFamily="34" charset="0"/>
                 <a:ea typeface="Palatino" pitchFamily="2" charset="77"/>
               </a:rPr>
               <a:t>Full example in lab_04-hello_flutter/my_first_app/</a:t>
@@ -11932,12 +12029,12 @@
             <a:pPr algn="ctr"/>
             <a:r>
               <a:rPr lang="en-GB" b="1" dirty="0">
-                <a:latin typeface="Palatino Linotype" panose="02040502050505030304" pitchFamily="18" charset="0"/>
+                <a:latin typeface="Aptos" panose="020B0004020202020204" pitchFamily="34" charset="0"/>
               </a:rPr>
               <a:t>How to use it? Docs!</a:t>
             </a:r>
             <a:endParaRPr lang="en-IT" dirty="0">
-              <a:latin typeface="Palatino Linotype" panose="02040502050505030304" pitchFamily="18" charset="0"/>
+              <a:latin typeface="Aptos" panose="020B0004020202020204" pitchFamily="34" charset="0"/>
             </a:endParaRPr>
           </a:p>
         </p:txBody>
@@ -12020,12 +12117,12 @@
             <a:pPr algn="ctr"/>
             <a:r>
               <a:rPr lang="en-GB" b="1" dirty="0">
-                <a:latin typeface="Palatino Linotype" panose="02040502050505030304" pitchFamily="18" charset="0"/>
+                <a:latin typeface="Aptos" panose="020B0004020202020204" pitchFamily="34" charset="0"/>
               </a:rPr>
               <a:t>Code is available too!</a:t>
             </a:r>
             <a:endParaRPr lang="en-IT" dirty="0">
-              <a:latin typeface="Palatino Linotype" panose="02040502050505030304" pitchFamily="18" charset="0"/>
+              <a:latin typeface="Aptos" panose="020B0004020202020204" pitchFamily="34" charset="0"/>
             </a:endParaRPr>
           </a:p>
         </p:txBody>
@@ -12758,7 +12855,7 @@
         </p:spPr>
         <p:txBody>
           <a:bodyPr>
-            <a:normAutofit lnSpcReduction="10000"/>
+            <a:normAutofit/>
           </a:bodyPr>
           <a:lstStyle/>
           <a:p>
@@ -13607,12 +13704,12 @@
             <a:pPr algn="ctr"/>
             <a:r>
               <a:rPr lang="en-GB" b="1" dirty="0">
-                <a:latin typeface="Palatino Linotype" panose="02040502050505030304" pitchFamily="18" charset="0"/>
+                <a:latin typeface="Aptos" panose="020B0004020202020204" pitchFamily="34" charset="0"/>
               </a:rPr>
               <a:t>Restart button</a:t>
             </a:r>
             <a:endParaRPr lang="en-IT" dirty="0">
-              <a:latin typeface="Palatino Linotype" panose="02040502050505030304" pitchFamily="18" charset="0"/>
+              <a:latin typeface="Aptos" panose="020B0004020202020204" pitchFamily="34" charset="0"/>
             </a:endParaRPr>
           </a:p>
         </p:txBody>
@@ -13696,12 +13793,12 @@
             <a:pPr algn="ctr"/>
             <a:r>
               <a:rPr lang="en-GB" b="1" dirty="0">
-                <a:latin typeface="Palatino Linotype" panose="02040502050505030304" pitchFamily="18" charset="0"/>
+                <a:latin typeface="Aptos" panose="020B0004020202020204" pitchFamily="34" charset="0"/>
               </a:rPr>
               <a:t>Reload button</a:t>
             </a:r>
             <a:endParaRPr lang="en-IT" dirty="0">
-              <a:latin typeface="Palatino Linotype" panose="02040502050505030304" pitchFamily="18" charset="0"/>
+              <a:latin typeface="Aptos" panose="020B0004020202020204" pitchFamily="34" charset="0"/>
             </a:endParaRPr>
           </a:p>
         </p:txBody>
@@ -21884,10 +21981,16 @@
               <a:rPr lang="en-GB" sz="2000" dirty="0">
                 <a:latin typeface="Palatino Linotype" panose="02040502050505030304" pitchFamily="18" charset="0"/>
               </a:rPr>
-              <a:t> is a special method that is called the first time the Widget is created. It is used (as its name suggest) to initialize the state of the Widget itself.</a:t>
+              <a:t> </a:t>
+            </a:r>
+            <a:r>
+              <a:rPr lang="en-GB" sz="2000" dirty="0">
+                <a:latin typeface="Aptos" panose="020B0004020202020204" pitchFamily="34" charset="0"/>
+              </a:rPr>
+              <a:t>is a special method that is called the first time the Widget is created. It is used (as its name suggest) to initialize the state of the Widget itself.</a:t>
             </a:r>
             <a:endParaRPr lang="en-IT" sz="2000" dirty="0">
-              <a:latin typeface="Courier" pitchFamily="2" charset="0"/>
+              <a:latin typeface="Aptos" panose="020B0004020202020204" pitchFamily="34" charset="0"/>
             </a:endParaRPr>
           </a:p>
         </p:txBody>
@@ -21927,12 +22030,12 @@
             </a:r>
             <a:r>
               <a:rPr lang="en-GB" sz="2000" dirty="0">
-                <a:latin typeface="Palatino Linotype" panose="02040502050505030304" pitchFamily="18" charset="0"/>
+                <a:latin typeface="Aptos" panose="020B0004020202020204" pitchFamily="34" charset="0"/>
               </a:rPr>
               <a:t>will represent the state of the Widget</a:t>
             </a:r>
             <a:endParaRPr lang="en-IT" sz="2000" dirty="0">
-              <a:latin typeface="Palatino Linotype" panose="02040502050505030304" pitchFamily="18" charset="0"/>
+              <a:latin typeface="Aptos" panose="020B0004020202020204" pitchFamily="34" charset="0"/>
             </a:endParaRPr>
           </a:p>
         </p:txBody>
@@ -22098,11 +22201,15 @@
               <a:t>We are ready to implement the function to provide to </a:t>
             </a:r>
             <a:r>
-              <a:rPr lang="en-US" dirty="0" err="1"/>
+              <a:rPr lang="en-US" dirty="0" err="1">
+                <a:latin typeface="Courier New" panose="02070309020205020404" pitchFamily="49" charset="0"/>
+                <a:cs typeface="Courier New" panose="02070309020205020404" pitchFamily="49" charset="0"/>
+              </a:rPr>
               <a:t>onPressed</a:t>
             </a:r>
             <a:endParaRPr lang="en-US" b="1" dirty="0">
-              <a:latin typeface="Courier" pitchFamily="2" charset="0"/>
+              <a:latin typeface="Courier New" panose="02070309020205020404" pitchFamily="49" charset="0"/>
+              <a:cs typeface="Courier New" panose="02070309020205020404" pitchFamily="49" charset="0"/>
             </a:endParaRPr>
           </a:p>
           <a:p>
@@ -22493,34 +22600,41 @@
               <a:rPr lang="en-GB" sz="2000" dirty="0">
                 <a:latin typeface="Palatino Linotype" panose="02040502050505030304" pitchFamily="18" charset="0"/>
               </a:rPr>
-              <a:t> is a special method that requires a </a:t>
+              <a:t> </a:t>
+            </a:r>
+            <a:r>
+              <a:rPr lang="en-GB" sz="2000" dirty="0">
+                <a:latin typeface="Aptos" panose="020B0004020202020204" pitchFamily="34" charset="0"/>
+              </a:rPr>
+              <a:t>is a special method that requires a </a:t>
             </a:r>
             <a:r>
               <a:rPr lang="en-GB" sz="2000" dirty="0" err="1">
-                <a:latin typeface="Palatino Linotype" panose="02040502050505030304" pitchFamily="18" charset="0"/>
+                <a:latin typeface="Aptos" panose="020B0004020202020204" pitchFamily="34" charset="0"/>
               </a:rPr>
               <a:t>callback</a:t>
             </a:r>
             <a:r>
               <a:rPr lang="en-GB" sz="2000" dirty="0">
-                <a:latin typeface="Palatino Linotype" panose="02040502050505030304" pitchFamily="18" charset="0"/>
+                <a:latin typeface="Aptos" panose="020B0004020202020204" pitchFamily="34" charset="0"/>
               </a:rPr>
               <a:t> function as input. </a:t>
             </a:r>
             <a:r>
               <a:rPr lang="en-GB" sz="2000" dirty="0" err="1">
-                <a:latin typeface="Palatino Linotype" panose="02040502050505030304" pitchFamily="18" charset="0"/>
+                <a:latin typeface="Courier New" panose="02070309020205020404" pitchFamily="49" charset="0"/>
+                <a:cs typeface="Courier New" panose="02070309020205020404" pitchFamily="49" charset="0"/>
               </a:rPr>
               <a:t>setState</a:t>
             </a:r>
             <a:r>
               <a:rPr lang="en-GB" sz="2000" dirty="0">
-                <a:latin typeface="Palatino Linotype" panose="02040502050505030304" pitchFamily="18" charset="0"/>
+                <a:latin typeface="Aptos" panose="020B0004020202020204" pitchFamily="34" charset="0"/>
               </a:rPr>
               <a:t> notifies the Flutter framework that the state might be changed causing to delete and rebuild the widget itself.</a:t>
             </a:r>
             <a:endParaRPr lang="en-IT" sz="2000" dirty="0">
-              <a:latin typeface="Courier" pitchFamily="2" charset="0"/>
+              <a:latin typeface="Aptos" panose="020B0004020202020204" pitchFamily="34" charset="0"/>
             </a:endParaRPr>
           </a:p>
         </p:txBody>
@@ -23089,6 +23203,7 @@
             </a:pPr>
             <a:r>
               <a:rPr lang="en-IT" sz="1600" dirty="0">
+                <a:latin typeface="Aptos" panose="020B0004020202020204" pitchFamily="34" charset="0"/>
                 <a:ea typeface="Palatino" pitchFamily="2" charset="77"/>
               </a:rPr>
               <a:t>Full example in lab_04-hello_flutter/my_first_app_with_steroids/</a:t>
@@ -25130,7 +25245,7 @@
         </p:spPr>
         <p:txBody>
           <a:bodyPr>
-            <a:normAutofit lnSpcReduction="10000"/>
+            <a:normAutofit/>
           </a:bodyPr>
           <a:lstStyle/>
           <a:p>

</xml_diff>